<commit_message>
Refactor y mejora de la generación de presentaciones educativas, incluyendo soporte para formato Markdown y actualización de herramientas en el cliente Claude.
</commit_message>
<xml_diff>
--- a/PLANTILLA_QCA.pptx
+++ b/PLANTILLA_QCA.pptx
@@ -290,7 +290,7 @@
       </p15:sldGuideLst>
     </p:ext>
     <p:ext uri="GoogleSlidesCustomDataVersion2">
-      <go:slidesCustomData xmlns="" xmlns:mc="http://schemas.openxmlformats.org/markup-compatibility/2006" xmlns:mv="urn:schemas-microsoft-com:mac:vml" xmlns:c="http://schemas.openxmlformats.org/drawingml/2006/chart" xmlns:dgm="http://schemas.openxmlformats.org/drawingml/2006/diagram" xmlns:o="urn:schemas-microsoft-com:office:office" xmlns:v="urn:schemas-microsoft-com:vml" xmlns:pvml="urn:schemas-microsoft-com:office:powerpoint" xmlns:com="http://schemas.openxmlformats.org/drawingml/2006/compatibility" xmlns:p14="http://schemas.microsoft.com/office/powerpoint/2010/main" xmlns:p15="http://schemas.microsoft.com/office/powerpoint/2012/main" xmlns:ahyp="http://schemas.microsoft.com/office/drawing/2018/hyperlinkcolor" xmlns:go="http://customooxmlschemas.google.com/" r:id="rId51" roundtripDataSignature="AMtx7miw0p73h7ldKOtk4YFiDGGUra73+w=="/>
+      <go:slidesCustomData xmlns:go="http://customooxmlschemas.google.com/" xmlns:ahyp="http://schemas.microsoft.com/office/drawing/2018/hyperlinkcolor" xmlns:p15="http://schemas.microsoft.com/office/powerpoint/2012/main" xmlns:p14="http://schemas.microsoft.com/office/powerpoint/2010/main" xmlns:com="http://schemas.openxmlformats.org/drawingml/2006/compatibility" xmlns:pvml="urn:schemas-microsoft-com:office:powerpoint" xmlns:v="urn:schemas-microsoft-com:vml" xmlns:o="urn:schemas-microsoft-com:office:office" xmlns:dgm="http://schemas.openxmlformats.org/drawingml/2006/diagram" xmlns:c="http://schemas.openxmlformats.org/drawingml/2006/chart" xmlns:mv="urn:schemas-microsoft-com:mac:vml" xmlns:mc="http://schemas.openxmlformats.org/markup-compatibility/2006" xmlns="" r:id="rId51" roundtripDataSignature="AMtx7miw0p73h7ldKOtk4YFiDGGUra73+w=="/>
     </p:ext>
   </p:extLst>
 </p:presentation>
@@ -27901,16 +27901,18 @@
           <a:lstStyle/>
           <a:p>
             <a:r>
-              <a:rPr lang="es-419" b="1" dirty="0">
+              <a:rPr lang="es-419" b="1">
                 <a:solidFill>
                   <a:srgbClr val="000000"/>
                 </a:solidFill>
               </a:rPr>
-              <a:t> {{OC}}</a:t>
+              <a:t> {OC}</a:t>
             </a:r>
-          </a:p>
-          <a:p>
-            <a:endParaRPr lang="es-CL" dirty="0"/>
+            <a:endParaRPr lang="es-419" b="1" dirty="0">
+              <a:solidFill>
+                <a:srgbClr val="000000"/>
+              </a:solidFill>
+            </a:endParaRPr>
           </a:p>
         </p:txBody>
       </p:sp>
@@ -28044,7 +28046,7 @@
             </a:pPr>
             <a:r>
               <a:rPr lang="es-419" sz="2000" dirty="0"/>
-              <a:t>        CURSO: {{CURSO}}                   ASIGNATURA: {{ASIGNATURA}}</a:t>
+              <a:t>        CURSO: {CURSO}                   ASIGNATURA: {ASIGNATURA}</a:t>
             </a:r>
             <a:endParaRPr sz="2000" dirty="0"/>
           </a:p>
@@ -28295,31 +28297,7 @@
                 <a:cs typeface="Georgia"/>
                 <a:sym typeface="Georgia"/>
               </a:rPr>
-              <a:t>CLASE </a:t>
-            </a:r>
-            <a:r>
-              <a:rPr lang="es-419" sz="2000" b="1" i="0" u="none" strike="noStrike" cap="none" dirty="0" err="1">
-                <a:solidFill>
-                  <a:srgbClr val="003A48"/>
-                </a:solidFill>
-                <a:latin typeface="Georgia"/>
-                <a:ea typeface="Georgia"/>
-                <a:cs typeface="Georgia"/>
-                <a:sym typeface="Georgia"/>
-              </a:rPr>
-              <a:t>N°</a:t>
-            </a:r>
-            <a:r>
-              <a:rPr lang="es-419" sz="2000" b="1" i="0" u="none" strike="noStrike" cap="none" dirty="0">
-                <a:solidFill>
-                  <a:srgbClr val="003A48"/>
-                </a:solidFill>
-                <a:latin typeface="Georgia"/>
-                <a:ea typeface="Georgia"/>
-                <a:cs typeface="Georgia"/>
-                <a:sym typeface="Georgia"/>
-              </a:rPr>
-              <a:t> {{NC}}</a:t>
+              <a:t>CLASE N° {NC}</a:t>
             </a:r>
             <a:endParaRPr sz="1400" b="1" i="0" u="none" strike="noStrike" cap="none" dirty="0">
               <a:solidFill>
@@ -30640,15 +30618,7 @@
             </a:pPr>
             <a:r>
               <a:rPr lang="es-419" sz="2000" b="1" dirty="0"/>
-              <a:t>CLASE </a:t>
-            </a:r>
-            <a:r>
-              <a:rPr lang="es-419" sz="2000" b="1" dirty="0" err="1"/>
-              <a:t>N°</a:t>
-            </a:r>
-            <a:r>
-              <a:rPr lang="es-419" sz="2000" b="1" dirty="0"/>
-              <a:t>: {{NC}}</a:t>
+              <a:t>CLASE N°: {NC}</a:t>
             </a:r>
             <a:endParaRPr sz="1500" b="1" dirty="0"/>
           </a:p>
@@ -30717,7 +30687,7 @@
                   <a:schemeClr val="dk2"/>
                 </a:solidFill>
               </a:rPr>
-              <a:t>{{UNIDAD}}</a:t>
+              <a:t>{UNIDAD}</a:t>
             </a:r>
             <a:endParaRPr lang="es-419" b="1" dirty="0"/>
           </a:p>
@@ -30750,7 +30720,7 @@
                   <a:schemeClr val="dk2"/>
                 </a:solidFill>
               </a:rPr>
-              <a:t>{{CONTENIDOS}}</a:t>
+              <a:t>{CONTENIDOS}</a:t>
             </a:r>
           </a:p>
           <a:p>
@@ -30833,7 +30803,7 @@
                 <a:cs typeface="Book Antiqua"/>
                 <a:sym typeface="Book Antiqua"/>
               </a:rPr>
-              <a:t> {{OA}}.</a:t>
+              <a:t> {OA}.</a:t>
             </a:r>
             <a:endParaRPr b="1" dirty="0">
               <a:solidFill>
@@ -30993,7 +30963,7 @@
                 <a:latin typeface="Book Antiqua"/>
                 <a:sym typeface="Book Antiqua"/>
               </a:rPr>
-              <a:t>{{HABILIDADES}}</a:t>
+              <a:t>{HABILIDADES}</a:t>
             </a:r>
           </a:p>
           <a:p>
@@ -31052,7 +31022,7 @@
                 <a:latin typeface="Book Antiqua"/>
                 <a:sym typeface="Book Antiqua"/>
               </a:rPr>
-              <a:t>VIRTUD: {{VIRTUD}}</a:t>
+              <a:t>VIRTUD: {VIRTUD}</a:t>
             </a:r>
             <a:endParaRPr sz="1800" b="1" dirty="0"/>
           </a:p>

</xml_diff>

<commit_message>
Mejorar la gestión de presentaciones: actualizar .gitignore, agregar soporte para archivos PPTX, y refactorizar el procesamiento de referencias en el servidor MCP. También se incluye un nuevo script cliente y ajustes en la visualización del logo.
</commit_message>
<xml_diff>
--- a/PLANTILLA_QCA.pptx
+++ b/PLANTILLA_QCA.pptx
@@ -290,7 +290,7 @@
       </p15:sldGuideLst>
     </p:ext>
     <p:ext uri="GoogleSlidesCustomDataVersion2">
-      <go:slidesCustomData xmlns:go="http://customooxmlschemas.google.com/" xmlns:ahyp="http://schemas.microsoft.com/office/drawing/2018/hyperlinkcolor" xmlns:p15="http://schemas.microsoft.com/office/powerpoint/2012/main" xmlns:p14="http://schemas.microsoft.com/office/powerpoint/2010/main" xmlns:com="http://schemas.openxmlformats.org/drawingml/2006/compatibility" xmlns:pvml="urn:schemas-microsoft-com:office:powerpoint" xmlns:v="urn:schemas-microsoft-com:vml" xmlns:o="urn:schemas-microsoft-com:office:office" xmlns:dgm="http://schemas.openxmlformats.org/drawingml/2006/diagram" xmlns:c="http://schemas.openxmlformats.org/drawingml/2006/chart" xmlns:mv="urn:schemas-microsoft-com:mac:vml" xmlns:mc="http://schemas.openxmlformats.org/markup-compatibility/2006" xmlns="" r:id="rId51" roundtripDataSignature="AMtx7miw0p73h7ldKOtk4YFiDGGUra73+w=="/>
+      <go:slidesCustomData xmlns="" xmlns:mc="http://schemas.openxmlformats.org/markup-compatibility/2006" xmlns:mv="urn:schemas-microsoft-com:mac:vml" xmlns:c="http://schemas.openxmlformats.org/drawingml/2006/chart" xmlns:dgm="http://schemas.openxmlformats.org/drawingml/2006/diagram" xmlns:o="urn:schemas-microsoft-com:office:office" xmlns:v="urn:schemas-microsoft-com:vml" xmlns:pvml="urn:schemas-microsoft-com:office:powerpoint" xmlns:com="http://schemas.openxmlformats.org/drawingml/2006/compatibility" xmlns:p14="http://schemas.microsoft.com/office/powerpoint/2010/main" xmlns:p15="http://schemas.microsoft.com/office/powerpoint/2012/main" xmlns:ahyp="http://schemas.microsoft.com/office/drawing/2018/hyperlinkcolor" xmlns:go="http://customooxmlschemas.google.com/" r:id="rId51" roundtripDataSignature="AMtx7miw0p73h7ldKOtk4YFiDGGUra73+w=="/>
     </p:ext>
   </p:extLst>
 </p:presentation>
@@ -27901,18 +27901,13 @@
           <a:lstStyle/>
           <a:p>
             <a:r>
-              <a:rPr lang="es-419" b="1">
+              <a:rPr lang="es-419" b="1" dirty="0">
                 <a:solidFill>
                   <a:srgbClr val="000000"/>
                 </a:solidFill>
               </a:rPr>
-              <a:t> {OC}</a:t>
+              <a:t> {{OC}}</a:t>
             </a:r>
-            <a:endParaRPr lang="es-419" b="1" dirty="0">
-              <a:solidFill>
-                <a:srgbClr val="000000"/>
-              </a:solidFill>
-            </a:endParaRPr>
           </a:p>
         </p:txBody>
       </p:sp>
@@ -28046,7 +28041,7 @@
             </a:pPr>
             <a:r>
               <a:rPr lang="es-419" sz="2000" dirty="0"/>
-              <a:t>        CURSO: {CURSO}                   ASIGNATURA: {ASIGNATURA}</a:t>
+              <a:t>        CURSO: {{CURSO}}                   ASIGNATURA: {{ASIGNATURA}}</a:t>
             </a:r>
             <a:endParaRPr sz="2000" dirty="0"/>
           </a:p>
@@ -28297,7 +28292,31 @@
                 <a:cs typeface="Georgia"/>
                 <a:sym typeface="Georgia"/>
               </a:rPr>
-              <a:t>CLASE N° {NC}</a:t>
+              <a:t>CLASE </a:t>
+            </a:r>
+            <a:r>
+              <a:rPr lang="es-419" sz="2000" b="1" i="0" u="none" strike="noStrike" cap="none" dirty="0" err="1">
+                <a:solidFill>
+                  <a:srgbClr val="003A48"/>
+                </a:solidFill>
+                <a:latin typeface="Georgia"/>
+                <a:ea typeface="Georgia"/>
+                <a:cs typeface="Georgia"/>
+                <a:sym typeface="Georgia"/>
+              </a:rPr>
+              <a:t>N°</a:t>
+            </a:r>
+            <a:r>
+              <a:rPr lang="es-419" sz="2000" b="1" i="0" u="none" strike="noStrike" cap="none" dirty="0">
+                <a:solidFill>
+                  <a:srgbClr val="003A48"/>
+                </a:solidFill>
+                <a:latin typeface="Georgia"/>
+                <a:ea typeface="Georgia"/>
+                <a:cs typeface="Georgia"/>
+                <a:sym typeface="Georgia"/>
+              </a:rPr>
+              <a:t> {{NC}}</a:t>
             </a:r>
             <a:endParaRPr sz="1400" b="1" i="0" u="none" strike="noStrike" cap="none" dirty="0">
               <a:solidFill>
@@ -30618,7 +30637,15 @@
             </a:pPr>
             <a:r>
               <a:rPr lang="es-419" sz="2000" b="1" dirty="0"/>
-              <a:t>CLASE N°: {NC}</a:t>
+              <a:t>CLASE </a:t>
+            </a:r>
+            <a:r>
+              <a:rPr lang="es-419" sz="2000" b="1" dirty="0" err="1"/>
+              <a:t>N°</a:t>
+            </a:r>
+            <a:r>
+              <a:rPr lang="es-419" sz="2000" b="1" dirty="0"/>
+              <a:t>: {{NC}}</a:t>
             </a:r>
             <a:endParaRPr sz="1500" b="1" dirty="0"/>
           </a:p>
@@ -30687,7 +30714,7 @@
                   <a:schemeClr val="dk2"/>
                 </a:solidFill>
               </a:rPr>
-              <a:t>{UNIDAD}</a:t>
+              <a:t>{{UNIDAD}}</a:t>
             </a:r>
             <a:endParaRPr lang="es-419" b="1" dirty="0"/>
           </a:p>
@@ -30720,7 +30747,7 @@
                   <a:schemeClr val="dk2"/>
                 </a:solidFill>
               </a:rPr>
-              <a:t>{CONTENIDOS}</a:t>
+              <a:t>{{CONTENIDOS}}</a:t>
             </a:r>
           </a:p>
           <a:p>
@@ -30803,7 +30830,7 @@
                 <a:cs typeface="Book Antiqua"/>
                 <a:sym typeface="Book Antiqua"/>
               </a:rPr>
-              <a:t> {OA}.</a:t>
+              <a:t> {{OA}}.</a:t>
             </a:r>
             <a:endParaRPr b="1" dirty="0">
               <a:solidFill>
@@ -30963,7 +30990,7 @@
                 <a:latin typeface="Book Antiqua"/>
                 <a:sym typeface="Book Antiqua"/>
               </a:rPr>
-              <a:t>{HABILIDADES}</a:t>
+              <a:t>{{HABILIDADES}}</a:t>
             </a:r>
           </a:p>
           <a:p>
@@ -31022,7 +31049,7 @@
                 <a:latin typeface="Book Antiqua"/>
                 <a:sym typeface="Book Antiqua"/>
               </a:rPr>
-              <a:t>VIRTUD: {VIRTUD}</a:t>
+              <a:t>VIRTUD: {{VIRTUD}}</a:t>
             </a:r>
             <a:endParaRPr sz="1800" b="1" dirty="0"/>
           </a:p>

</xml_diff>